<commit_message>
Updated NHSN FHIR dQMs.pptx
</commit_message>
<xml_diff>
--- a/input/images/NHSN FHIR dQMs.pptx
+++ b/input/images/NHSN FHIR dQMs.pptx
@@ -8,7 +8,7 @@
     <p:notesMasterId r:id="rId4"/>
   </p:notesMasterIdLst>
   <p:sldIdLst>
-    <p:sldId id="2147474245" r:id="rId2"/>
+    <p:sldId id="2147474244" r:id="rId2"/>
     <p:sldId id="2147474226" r:id="rId3"/>
   </p:sldIdLst>
   <p:sldSz cx="12192000" cy="6858000"/>
@@ -108,6 +108,11 @@
       </a:defRPr>
     </a:lvl9pPr>
   </p:defaultTextStyle>
+  <p:extLst>
+    <p:ext uri="{EFAFB233-063F-42B5-8137-9DF3F51BA10A}">
+      <p15:sldGuideLst xmlns:p15="http://schemas.microsoft.com/office/powerpoint/2012/main"/>
+    </p:ext>
+  </p:extLst>
 </p:presentation>
 </file>
 
@@ -523,71 +528,17 @@
           <a:bodyPr/>
           <a:lstStyle/>
           <a:p>
-            <a:pPr marL="0" marR="0" lvl="0" indent="0" algn="r" defTabSz="914400" rtl="0" eaLnBrk="1" fontAlgn="auto" latinLnBrk="0" hangingPunct="1">
-              <a:lnSpc>
-                <a:spcPct val="100000"/>
-              </a:lnSpc>
-              <a:spcBef>
-                <a:spcPts val="0"/>
-              </a:spcBef>
-              <a:spcAft>
-                <a:spcPts val="0"/>
-              </a:spcAft>
-              <a:buClrTx/>
-              <a:buSzTx/>
-              <a:buFontTx/>
-              <a:buNone/>
-              <a:tabLst/>
+            <a:pPr>
               <a:defRPr/>
             </a:pPr>
             <a:fld id="{EB38CAEC-4554-485B-9189-C45C7447A404}" type="slidenum">
-              <a:rPr kumimoji="0" lang="en-US" sz="1200" b="0" i="0" u="none" strike="noStrike" kern="1200" cap="none" spc="0" normalizeH="0" baseline="0" noProof="0" smtClean="0">
-                <a:ln>
-                  <a:noFill/>
-                </a:ln>
-                <a:solidFill>
-                  <a:prstClr val="black"/>
-                </a:solidFill>
-                <a:effectLst/>
-                <a:uLnTx/>
-                <a:uFillTx/>
-                <a:latin typeface="Calibri"/>
-                <a:ea typeface="+mn-ea"/>
-                <a:cs typeface="+mn-cs"/>
-              </a:rPr>
-              <a:pPr marL="0" marR="0" lvl="0" indent="0" algn="r" defTabSz="914400" rtl="0" eaLnBrk="1" fontAlgn="auto" latinLnBrk="0" hangingPunct="1">
-                <a:lnSpc>
-                  <a:spcPct val="100000"/>
-                </a:lnSpc>
-                <a:spcBef>
-                  <a:spcPts val="0"/>
-                </a:spcBef>
-                <a:spcAft>
-                  <a:spcPts val="0"/>
-                </a:spcAft>
-                <a:buClrTx/>
-                <a:buSzTx/>
-                <a:buFontTx/>
-                <a:buNone/>
-                <a:tabLst/>
+              <a:rPr lang="en-US" smtClean="0"/>
+              <a:pPr>
                 <a:defRPr/>
               </a:pPr>
               <a:t>1</a:t>
             </a:fld>
-            <a:endParaRPr kumimoji="0" lang="en-US" sz="1200" b="0" i="0" u="none" strike="noStrike" kern="1200" cap="none" spc="0" normalizeH="0" baseline="0" noProof="0">
-              <a:ln>
-                <a:noFill/>
-              </a:ln>
-              <a:solidFill>
-                <a:prstClr val="black"/>
-              </a:solidFill>
-              <a:effectLst/>
-              <a:uLnTx/>
-              <a:uFillTx/>
-              <a:latin typeface="Calibri"/>
-              <a:ea typeface="+mn-ea"/>
-              <a:cs typeface="+mn-cs"/>
-            </a:endParaRPr>
+            <a:endParaRPr lang="en-US"/>
           </a:p>
         </p:txBody>
       </p:sp>
@@ -3245,7 +3196,6 @@
               <a:effectLst/>
               <a:uLnTx/>
               <a:uFillTx/>
-              <a:latin typeface="Myriad Web Pro"/>
               <a:ea typeface="+mn-ea"/>
               <a:cs typeface="+mn-cs"/>
             </a:endParaRPr>
@@ -3322,7 +3272,6 @@
               <a:effectLst/>
               <a:uLnTx/>
               <a:uFillTx/>
-              <a:latin typeface="Myriad Web Pro"/>
               <a:ea typeface="+mn-ea"/>
               <a:cs typeface="Calibri" panose="020F0502020204030204" pitchFamily="34" charset="0"/>
             </a:endParaRPr>
@@ -3423,7 +3372,6 @@
                 <a:effectLst/>
                 <a:uLnTx/>
                 <a:uFillTx/>
-                <a:latin typeface="Myriad Web Pro"/>
                 <a:ea typeface="+mn-ea"/>
                 <a:cs typeface="+mn-cs"/>
               </a:endParaRPr>
@@ -3502,7 +3450,6 @@
                 <a:effectLst/>
                 <a:uLnTx/>
                 <a:uFillTx/>
-                <a:latin typeface="Myriad Web Pro"/>
                 <a:ea typeface="+mn-ea"/>
                 <a:cs typeface="+mn-cs"/>
               </a:endParaRPr>
@@ -3570,20 +3517,19 @@
                 <a:defRPr/>
               </a:pPr>
               <a:r>
-                <a:rPr kumimoji="0" lang="en-US" sz="1800" b="1" i="0" u="none" strike="noStrike" kern="1200" cap="none" spc="0" normalizeH="0" baseline="0" noProof="0" dirty="0">
+                <a:rPr kumimoji="0" lang="en-US" b="1" i="0" u="none" strike="noStrike" kern="1200" cap="none" spc="0" normalizeH="0" baseline="0" noProof="0" dirty="0">
                   <a:ln>
                     <a:noFill/>
                   </a:ln>
                   <a:solidFill>
-                    <a:srgbClr val="0F56DC">
+                    <a:schemeClr val="tx1">
                       <a:lumMod val="75000"/>
-                    </a:srgbClr>
+                    </a:schemeClr>
                   </a:solidFill>
                   <a:effectLst/>
                   <a:uLnTx/>
                   <a:uFillTx/>
                   <a:latin typeface="Calibri" panose="020F0502020204030204" pitchFamily="34" charset="0"/>
-                  <a:ea typeface="+mn-ea"/>
                   <a:cs typeface="Calibri" panose="020F0502020204030204" pitchFamily="34" charset="0"/>
                 </a:rPr>
                 <a:t>NHSNLink identifies patients of interest from EHR*</a:t>
@@ -3652,52 +3598,43 @@
                 <a:defRPr/>
               </a:pPr>
               <a:r>
-                <a:rPr kumimoji="0" lang="en-US" sz="1800" b="1" i="0" u="none" strike="noStrike" kern="1200" cap="none" spc="0" normalizeH="0" baseline="0" noProof="0" dirty="0">
+                <a:rPr lang="en-US" b="1" dirty="0">
+                  <a:solidFill>
+                    <a:schemeClr val="accent6"/>
+                  </a:solidFill>
+                  <a:latin typeface="Calibri" panose="020F0502020204030204" pitchFamily="34" charset="0"/>
+                  <a:cs typeface="Calibri" panose="020F0502020204030204" pitchFamily="34" charset="0"/>
+                </a:rPr>
+                <a:t>NHSNLink q</a:t>
+              </a:r>
+              <a:r>
+                <a:rPr kumimoji="0" lang="en-US" b="1" i="0" u="none" strike="noStrike" kern="1200" cap="none" spc="0" normalizeH="0" baseline="0" noProof="0" dirty="0" err="1">
                   <a:ln>
                     <a:noFill/>
                   </a:ln>
                   <a:solidFill>
-                    <a:srgbClr val="002060"/>
+                    <a:schemeClr val="accent6"/>
                   </a:solidFill>
                   <a:effectLst/>
                   <a:uLnTx/>
                   <a:uFillTx/>
                   <a:latin typeface="Calibri" panose="020F0502020204030204" pitchFamily="34" charset="0"/>
-                  <a:ea typeface="+mn-ea"/>
                   <a:cs typeface="Calibri" panose="020F0502020204030204" pitchFamily="34" charset="0"/>
                 </a:rPr>
-                <a:t>NHSNLink q</a:t>
+                <a:t>ueries</a:t>
               </a:r>
               <a:r>
-                <a:rPr kumimoji="0" lang="en-US" sz="1800" b="1" i="0" u="none" strike="noStrike" kern="1200" cap="none" spc="0" normalizeH="0" baseline="0" noProof="0" dirty="0" err="1">
+                <a:rPr kumimoji="0" lang="en-US" b="1" i="0" u="none" strike="noStrike" kern="1200" cap="none" spc="0" normalizeH="0" baseline="0" noProof="0" dirty="0">
                   <a:ln>
                     <a:noFill/>
                   </a:ln>
                   <a:solidFill>
-                    <a:srgbClr val="002060"/>
+                    <a:schemeClr val="accent6"/>
                   </a:solidFill>
                   <a:effectLst/>
                   <a:uLnTx/>
                   <a:uFillTx/>
                   <a:latin typeface="Calibri" panose="020F0502020204030204" pitchFamily="34" charset="0"/>
-                  <a:ea typeface="+mn-ea"/>
-                  <a:cs typeface="Calibri" panose="020F0502020204030204" pitchFamily="34" charset="0"/>
-                </a:rPr>
-                <a:t>ueries</a:t>
-              </a:r>
-              <a:r>
-                <a:rPr kumimoji="0" lang="en-US" sz="1800" b="1" i="0" u="none" strike="noStrike" kern="1200" cap="none" spc="0" normalizeH="0" baseline="0" noProof="0" dirty="0">
-                  <a:ln>
-                    <a:noFill/>
-                  </a:ln>
-                  <a:solidFill>
-                    <a:srgbClr val="002060"/>
-                  </a:solidFill>
-                  <a:effectLst/>
-                  <a:uLnTx/>
-                  <a:uFillTx/>
-                  <a:latin typeface="Calibri" panose="020F0502020204030204" pitchFamily="34" charset="0"/>
-                  <a:ea typeface="+mn-ea"/>
                   <a:cs typeface="Calibri" panose="020F0502020204030204" pitchFamily="34" charset="0"/>
                 </a:rPr>
                 <a:t> EHR to identify data elements required to calculate measures (e.g., medications, labs) for patients of interest</a:t>
@@ -3771,13 +3708,12 @@
                     <a:noFill/>
                   </a:ln>
                   <a:solidFill>
-                    <a:srgbClr val="002060"/>
+                    <a:schemeClr val="accent6"/>
                   </a:solidFill>
                   <a:effectLst/>
                   <a:uLnTx/>
                   <a:uFillTx/>
                   <a:latin typeface="Calibri" panose="020F0502020204030204" pitchFamily="34" charset="0"/>
-                  <a:ea typeface="+mn-ea"/>
                   <a:cs typeface="Calibri" panose="020F0502020204030204" pitchFamily="34" charset="0"/>
                 </a:rPr>
                 <a:t>Data further validated and analyzed</a:t>
@@ -3845,17 +3781,16 @@
                 <a:tabLst/>
                 <a:defRPr/>
               </a:pPr>
-              <a:endParaRPr kumimoji="0" lang="en-US" sz="1800" b="0" i="0" u="none" strike="noStrike" kern="1200" cap="none" spc="0" normalizeH="0" baseline="0" noProof="0" dirty="0">
+              <a:endParaRPr kumimoji="0" lang="en-US" b="0" i="0" u="none" strike="noStrike" kern="1200" cap="none" spc="0" normalizeH="0" baseline="0" noProof="0" dirty="0">
                 <a:ln>
                   <a:noFill/>
                 </a:ln>
                 <a:solidFill>
-                  <a:srgbClr val="0F56DC"/>
+                  <a:schemeClr val="tx1"/>
                 </a:solidFill>
                 <a:effectLst/>
                 <a:uLnTx/>
                 <a:uFillTx/>
-                <a:latin typeface="Myriad Web Pro"/>
                 <a:ea typeface="+mn-ea"/>
                 <a:cs typeface="Calibri" panose="020F0502020204030204" pitchFamily="34" charset="0"/>
               </a:endParaRPr>
@@ -3879,21 +3814,46 @@
                 <a:defRPr/>
               </a:pPr>
               <a:r>
-                <a:rPr kumimoji="0" lang="en-US" sz="1800" b="1" i="0" u="none" strike="noStrike" kern="1200" cap="none" spc="0" normalizeH="0" baseline="0" noProof="0" dirty="0">
+                <a:rPr kumimoji="0" lang="en-US" b="1" i="0" u="none" strike="noStrike" kern="1200" cap="none" spc="0" normalizeH="0" baseline="0" noProof="0" dirty="0">
                   <a:ln>
                     <a:noFill/>
                   </a:ln>
                   <a:solidFill>
-                    <a:srgbClr val="FFFFFF"/>
+                    <a:schemeClr val="bg2"/>
                   </a:solidFill>
                   <a:effectLst/>
                   <a:uLnTx/>
                   <a:uFillTx/>
                   <a:latin typeface="Calibri" panose="020F0502020204030204" pitchFamily="34" charset="0"/>
-                  <a:ea typeface="+mn-ea"/>
                   <a:cs typeface="Calibri" panose="020F0502020204030204" pitchFamily="34" charset="0"/>
                 </a:rPr>
-                <a:t>NHSN application runs algorithms to determine if patient meets measure denominator and numerator criteria. Analytics performed and measure reports available for NHSN users.</a:t>
+                <a:t>NHSN application runs algorithms to determine if patient meets measure denominator and numerator criteria. Analytics performed and </a:t>
+              </a:r>
+              <a:r>
+                <a:rPr lang="en-US" b="1" dirty="0">
+                  <a:solidFill>
+                    <a:schemeClr val="bg2"/>
+                  </a:solidFill>
+                  <a:latin typeface="Calibri" panose="020F0502020204030204" pitchFamily="34" charset="0"/>
+                  <a:cs typeface="Calibri" panose="020F0502020204030204" pitchFamily="34" charset="0"/>
+                </a:rPr>
+                <a:t>measure reports </a:t>
+              </a:r>
+              <a:r>
+                <a:rPr kumimoji="0" lang="en-US" b="1" i="0" u="none" strike="noStrike" kern="1200" cap="none" spc="0" normalizeH="0" baseline="0" noProof="0" dirty="0">
+                  <a:ln>
+                    <a:noFill/>
+                  </a:ln>
+                  <a:solidFill>
+                    <a:schemeClr val="bg2"/>
+                  </a:solidFill>
+                  <a:effectLst/>
+                  <a:uLnTx/>
+                  <a:uFillTx/>
+                  <a:latin typeface="Calibri" panose="020F0502020204030204" pitchFamily="34" charset="0"/>
+                  <a:cs typeface="Calibri" panose="020F0502020204030204" pitchFamily="34" charset="0"/>
+                </a:rPr>
+                <a:t>available for NHSN users.</a:t>
               </a:r>
             </a:p>
           </p:txBody>
@@ -3949,15 +3909,14 @@
                     <a:noFill/>
                   </a:ln>
                   <a:solidFill>
-                    <a:srgbClr val="0F56DC">
+                    <a:schemeClr val="tx1">
                       <a:lumMod val="75000"/>
-                    </a:srgbClr>
+                    </a:schemeClr>
                   </a:solidFill>
                   <a:effectLst/>
                   <a:uLnTx/>
                   <a:uFillTx/>
                   <a:latin typeface="Calibri" panose="020F0502020204030204" pitchFamily="34" charset="0"/>
-                  <a:ea typeface="+mn-ea"/>
                   <a:cs typeface="Calibri" panose="020F0502020204030204" pitchFamily="34" charset="0"/>
                 </a:rPr>
                 <a:t>Facility</a:t>
@@ -4090,7 +4049,7 @@
           </a:fontRef>
         </p:style>
         <p:txBody>
-          <a:bodyPr rtlCol="0" anchor="ctr"/>
+          <a:bodyPr lIns="91440" tIns="45720" rIns="91440" bIns="45720" rtlCol="0" anchor="ctr"/>
           <a:lstStyle/>
           <a:p>
             <a:pPr marL="0" marR="0" lvl="0" indent="0" algn="ctr" defTabSz="1219170" rtl="0" eaLnBrk="0" fontAlgn="base" latinLnBrk="0" hangingPunct="0">
@@ -4111,22 +4070,36 @@
               <a:defRPr/>
             </a:pPr>
             <a:r>
-              <a:rPr kumimoji="0" lang="en-US" sz="1600" b="1" i="0" u="none" strike="noStrike" kern="1200" cap="none" spc="0" normalizeH="0" baseline="0" noProof="0" dirty="0">
+              <a:rPr kumimoji="0" lang="en-US" sz="1600" b="1" u="none" strike="noStrike" kern="1200" cap="none" spc="0" normalizeH="0" baseline="0" noProof="0" dirty="0">
                 <a:ln>
                   <a:noFill/>
                 </a:ln>
                 <a:solidFill>
-                  <a:srgbClr val="002060"/>
+                  <a:schemeClr val="accent6"/>
                 </a:solidFill>
                 <a:effectLst/>
                 <a:uLnTx/>
                 <a:uFillTx/>
-                <a:latin typeface="Calibri" panose="020F0502020204030204" pitchFamily="34" charset="0"/>
-                <a:ea typeface="+mn-ea"/>
-                <a:cs typeface="Calibri" panose="020F0502020204030204" pitchFamily="34" charset="0"/>
+                <a:latin typeface="Calibri"/>
+                <a:ea typeface="Calibri"/>
+                <a:cs typeface="Calibri"/>
               </a:rPr>
-              <a:t>NHSN connects securely to facility via FHIR API</a:t>
+              <a:t>NHSN connects securely to facility </a:t>
             </a:r>
+            <a:endParaRPr lang="en-US" sz="1600" b="1" u="none" strike="noStrike" kern="1200" cap="none" spc="0" normalizeH="0" baseline="0" noProof="0" dirty="0">
+              <a:ln>
+                <a:noFill/>
+              </a:ln>
+              <a:solidFill>
+                <a:schemeClr val="accent6"/>
+              </a:solidFill>
+              <a:effectLst/>
+              <a:uLnTx/>
+              <a:uFillTx/>
+              <a:latin typeface="Calibri"/>
+              <a:ea typeface="Calibri"/>
+              <a:cs typeface="Calibri"/>
+            </a:endParaRPr>
           </a:p>
         </p:txBody>
       </p:sp>
@@ -4177,37 +4150,8 @@
           <a:bodyPr rtlCol="0" anchor="ctr"/>
           <a:lstStyle/>
           <a:p>
-            <a:pPr marL="0" marR="0" lvl="0" indent="0" algn="ctr" defTabSz="914400" rtl="0" eaLnBrk="0" fontAlgn="base" latinLnBrk="0" hangingPunct="0">
-              <a:lnSpc>
-                <a:spcPct val="100000"/>
-              </a:lnSpc>
-              <a:spcBef>
-                <a:spcPct val="0"/>
-              </a:spcBef>
-              <a:spcAft>
-                <a:spcPct val="0"/>
-              </a:spcAft>
-              <a:buClrTx/>
-              <a:buSzTx/>
-              <a:buFontTx/>
-              <a:buNone/>
-              <a:tabLst/>
-              <a:defRPr/>
-            </a:pPr>
-            <a:endParaRPr kumimoji="0" lang="en-US" sz="1800" b="0" i="0" u="none" strike="noStrike" kern="1200" cap="none" spc="0" normalizeH="0" baseline="0" noProof="0">
-              <a:ln>
-                <a:noFill/>
-              </a:ln>
-              <a:solidFill>
-                <a:srgbClr val="FFFFFF"/>
-              </a:solidFill>
-              <a:effectLst/>
-              <a:uLnTx/>
-              <a:uFillTx/>
-              <a:latin typeface="Myriad Web Pro"/>
-              <a:ea typeface="+mn-ea"/>
-              <a:cs typeface="+mn-cs"/>
-            </a:endParaRPr>
+            <a:pPr algn="ctr"/>
+            <a:endParaRPr lang="en-US"/>
           </a:p>
         </p:txBody>
       </p:sp>
@@ -4258,37 +4202,8 @@
           <a:bodyPr rtlCol="0" anchor="ctr"/>
           <a:lstStyle/>
           <a:p>
-            <a:pPr marL="0" marR="0" lvl="0" indent="0" algn="ctr" defTabSz="914400" rtl="0" eaLnBrk="0" fontAlgn="base" latinLnBrk="0" hangingPunct="0">
-              <a:lnSpc>
-                <a:spcPct val="100000"/>
-              </a:lnSpc>
-              <a:spcBef>
-                <a:spcPct val="0"/>
-              </a:spcBef>
-              <a:spcAft>
-                <a:spcPct val="0"/>
-              </a:spcAft>
-              <a:buClrTx/>
-              <a:buSzTx/>
-              <a:buFontTx/>
-              <a:buNone/>
-              <a:tabLst/>
-              <a:defRPr/>
-            </a:pPr>
-            <a:endParaRPr kumimoji="0" lang="en-US" sz="1800" b="0" i="0" u="none" strike="noStrike" kern="1200" cap="none" spc="0" normalizeH="0" baseline="0" noProof="0">
-              <a:ln>
-                <a:noFill/>
-              </a:ln>
-              <a:solidFill>
-                <a:srgbClr val="FFFFFF"/>
-              </a:solidFill>
-              <a:effectLst/>
-              <a:uLnTx/>
-              <a:uFillTx/>
-              <a:latin typeface="Myriad Web Pro"/>
-              <a:ea typeface="+mn-ea"/>
-              <a:cs typeface="+mn-cs"/>
-            </a:endParaRPr>
+            <a:pPr algn="ctr"/>
+            <a:endParaRPr lang="en-US"/>
           </a:p>
         </p:txBody>
       </p:sp>
@@ -4337,34 +4252,11 @@
           <a:bodyPr rtlCol="0" anchor="ctr"/>
           <a:lstStyle/>
           <a:p>
-            <a:pPr marL="0" marR="0" lvl="0" indent="0" algn="l" defTabSz="914400" rtl="0" eaLnBrk="0" fontAlgn="base" latinLnBrk="0" hangingPunct="0">
-              <a:lnSpc>
-                <a:spcPct val="100000"/>
-              </a:lnSpc>
-              <a:spcBef>
-                <a:spcPct val="0"/>
-              </a:spcBef>
-              <a:spcAft>
-                <a:spcPct val="0"/>
-              </a:spcAft>
-              <a:buClrTx/>
-              <a:buSzTx/>
-              <a:buFontTx/>
-              <a:buNone/>
-              <a:tabLst/>
-              <a:defRPr/>
-            </a:pPr>
             <a:r>
-              <a:rPr kumimoji="0" lang="en-US" sz="1100" b="0" i="0" u="none" strike="noStrike" kern="1200" cap="none" spc="0" normalizeH="0" baseline="0" noProof="0" dirty="0">
-                <a:ln>
-                  <a:noFill/>
-                </a:ln>
-                <a:solidFill>
-                  <a:srgbClr val="002060"/>
-                </a:solidFill>
-                <a:effectLst/>
-                <a:uLnTx/>
-                <a:uFillTx/>
+              <a:rPr lang="en-US" sz="1100" dirty="0">
+                <a:solidFill>
+                  <a:schemeClr val="accent6"/>
+                </a:solidFill>
                 <a:latin typeface="Calibri" panose="020F0502020204030204" pitchFamily="34" charset="0"/>
                 <a:ea typeface="Calibri" panose="020F0502020204030204" pitchFamily="34" charset="0"/>
                 <a:cs typeface="Calibri" panose="020F0502020204030204" pitchFamily="34" charset="0"/>
@@ -4372,16 +4264,10 @@
               <a:t>*Patients in emergency department, observation, or inpatient </a:t>
             </a:r>
             <a:r>
-              <a:rPr kumimoji="0" lang="en-US" sz="1100" b="0" i="1" u="none" strike="noStrike" kern="1200" cap="none" spc="0" normalizeH="0" baseline="0" noProof="0" dirty="0">
-                <a:ln>
-                  <a:noFill/>
-                </a:ln>
-                <a:solidFill>
-                  <a:srgbClr val="002060"/>
-                </a:solidFill>
-                <a:effectLst/>
-                <a:uLnTx/>
-                <a:uFillTx/>
+              <a:rPr lang="en-US" sz="1100" i="1" dirty="0">
+                <a:solidFill>
+                  <a:schemeClr val="accent6"/>
+                </a:solidFill>
                 <a:latin typeface="Calibri" panose="020F0502020204030204" pitchFamily="34" charset="0"/>
                 <a:ea typeface="Calibri" panose="020F0502020204030204" pitchFamily="34" charset="0"/>
                 <a:cs typeface="Calibri" panose="020F0502020204030204" pitchFamily="34" charset="0"/>
@@ -4389,16 +4275,10 @@
               <a:t>location</a:t>
             </a:r>
             <a:r>
-              <a:rPr kumimoji="0" lang="en-US" sz="1100" b="0" i="0" u="none" strike="noStrike" kern="1200" cap="none" spc="0" normalizeH="0" baseline="0" noProof="0" dirty="0">
-                <a:ln>
-                  <a:noFill/>
-                </a:ln>
-                <a:solidFill>
-                  <a:srgbClr val="002060"/>
-                </a:solidFill>
-                <a:effectLst/>
-                <a:uLnTx/>
-                <a:uFillTx/>
+              <a:rPr lang="en-US" sz="1100" dirty="0">
+                <a:solidFill>
+                  <a:schemeClr val="accent6"/>
+                </a:solidFill>
                 <a:latin typeface="Calibri" panose="020F0502020204030204" pitchFamily="34" charset="0"/>
                 <a:ea typeface="Calibri" panose="020F0502020204030204" pitchFamily="34" charset="0"/>
                 <a:cs typeface="Calibri" panose="020F0502020204030204" pitchFamily="34" charset="0"/>
@@ -4406,16 +4286,10 @@
               <a:t> or </a:t>
             </a:r>
             <a:r>
-              <a:rPr kumimoji="0" lang="en-US" sz="1100" b="0" i="1" u="none" strike="noStrike" kern="1200" cap="none" spc="0" normalizeH="0" baseline="0" noProof="0" dirty="0">
-                <a:ln>
-                  <a:noFill/>
-                </a:ln>
-                <a:solidFill>
-                  <a:srgbClr val="002060"/>
-                </a:solidFill>
-                <a:effectLst/>
-                <a:uLnTx/>
-                <a:uFillTx/>
+              <a:rPr lang="en-US" sz="1100" i="1" dirty="0">
+                <a:solidFill>
+                  <a:schemeClr val="accent6"/>
+                </a:solidFill>
                 <a:latin typeface="Calibri" panose="020F0502020204030204" pitchFamily="34" charset="0"/>
                 <a:ea typeface="Calibri" panose="020F0502020204030204" pitchFamily="34" charset="0"/>
                 <a:cs typeface="Calibri" panose="020F0502020204030204" pitchFamily="34" charset="0"/>
@@ -4423,16 +4297,10 @@
               <a:t>status </a:t>
             </a:r>
             <a:r>
-              <a:rPr kumimoji="0" lang="en-US" sz="1100" b="0" i="0" u="none" strike="noStrike" kern="1200" cap="none" spc="0" normalizeH="0" baseline="0" noProof="0" dirty="0">
-                <a:ln>
-                  <a:noFill/>
-                </a:ln>
-                <a:solidFill>
-                  <a:srgbClr val="002060"/>
-                </a:solidFill>
-                <a:effectLst/>
-                <a:uLnTx/>
-                <a:uFillTx/>
+              <a:rPr lang="en-US" sz="1100" dirty="0">
+                <a:solidFill>
+                  <a:schemeClr val="accent6"/>
+                </a:solidFill>
                 <a:latin typeface="Calibri" panose="020F0502020204030204" pitchFamily="34" charset="0"/>
                 <a:ea typeface="Calibri" panose="020F0502020204030204" pitchFamily="34" charset="0"/>
                 <a:cs typeface="Calibri" panose="020F0502020204030204" pitchFamily="34" charset="0"/>
@@ -4440,16 +4308,10 @@
               <a:t>during the measurement period</a:t>
             </a:r>
             <a:r>
-              <a:rPr kumimoji="0" lang="en-US" sz="1100" b="0" i="0" u="none" strike="noStrike" kern="1200" cap="none" spc="0" normalizeH="0" baseline="0" noProof="0" dirty="0">
-                <a:ln>
-                  <a:noFill/>
-                </a:ln>
-                <a:solidFill>
-                  <a:srgbClr val="0F56DC"/>
-                </a:solidFill>
-                <a:effectLst/>
-                <a:uLnTx/>
-                <a:uFillTx/>
+              <a:rPr lang="en-US" sz="1100" dirty="0">
+                <a:solidFill>
+                  <a:schemeClr val="tx1"/>
+                </a:solidFill>
                 <a:latin typeface="Calibri" panose="020F0502020204030204" pitchFamily="34" charset="0"/>
                 <a:ea typeface="Calibri" panose="020F0502020204030204" pitchFamily="34" charset="0"/>
                 <a:cs typeface="Calibri" panose="020F0502020204030204" pitchFamily="34" charset="0"/>
@@ -4458,38 +4320,12 @@
             </a:r>
           </a:p>
           <a:p>
-            <a:pPr marL="0" marR="0" lvl="0" indent="0" algn="l" defTabSz="914400" rtl="0" eaLnBrk="0" fontAlgn="base" latinLnBrk="0" hangingPunct="0">
-              <a:lnSpc>
-                <a:spcPct val="100000"/>
-              </a:lnSpc>
-              <a:spcBef>
-                <a:spcPct val="0"/>
-              </a:spcBef>
-              <a:spcAft>
-                <a:spcPct val="0"/>
-              </a:spcAft>
-              <a:buClrTx/>
-              <a:buSzTx/>
-              <a:buFontTx/>
-              <a:buNone/>
-              <a:tabLst/>
-              <a:defRPr/>
-            </a:pPr>
-            <a:endParaRPr kumimoji="0" lang="en-US" sz="1800" b="0" i="0" u="none" strike="noStrike" kern="1200" cap="none" spc="0" normalizeH="0" baseline="0" noProof="0" dirty="0">
-              <a:ln>
-                <a:noFill/>
-              </a:ln>
+            <a:endParaRPr lang="en-US" dirty="0">
               <a:solidFill>
-                <a:srgbClr val="7F7F7F">
+                <a:schemeClr val="accent4">
                   <a:lumMod val="50000"/>
-                </a:srgbClr>
+                </a:schemeClr>
               </a:solidFill>
-              <a:effectLst/>
-              <a:uLnTx/>
-              <a:uFillTx/>
-              <a:latin typeface="Myriad Web Pro"/>
-              <a:ea typeface="+mn-ea"/>
-              <a:cs typeface="+mn-cs"/>
             </a:endParaRPr>
           </a:p>
         </p:txBody>
@@ -4527,7 +4363,7 @@
     </p:spTree>
     <p:extLst>
       <p:ext uri="{BB962C8B-B14F-4D97-AF65-F5344CB8AC3E}">
-        <p14:creationId xmlns:p14="http://schemas.microsoft.com/office/powerpoint/2010/main" val="3871955552"/>
+        <p14:creationId xmlns:p14="http://schemas.microsoft.com/office/powerpoint/2010/main" val="1610543809"/>
       </p:ext>
     </p:extLst>
   </p:cSld>

</xml_diff>